<commit_message>
story: reframe as an owner-facing 'is my car dangerous' safety check across app, report, pitch, and deck
</commit_message>
<xml_diff>
--- a/PITCH.pptx
+++ b/PITCH.pptx
@@ -3190,13 +3190,13 @@
               </a:spcAft>
             </a:pPr>
             <a:r>
-              <a:rPr sz="2400" b="0">
+              <a:rPr sz="2600" b="0">
                 <a:solidFill>
                   <a:srgbClr val="4CC9F0"/>
                 </a:solidFill>
                 <a:latin typeface="Calibri"/>
               </a:rPr>
-              <a:t>Reading vehicle safety complaints and routing them to the right system</a:t>
+              <a:t>Is your car problem a safety issue?</a:t>
             </a:r>
           </a:p>
           <a:p>
@@ -3375,7 +3375,7 @@
                 </a:solidFill>
                 <a:latin typeface="Calibri"/>
               </a:rPr>
-              <a:t>Drivers file hundreds of thousands of safety complaints with NHTSA every year</a:t>
+              <a:t>Your car does something odd, a noise, a warning light, a scary moment</a:t>
             </a:r>
           </a:p>
           <a:p>
@@ -3391,7 +3391,7 @@
                 </a:solidFill>
                 <a:latin typeface="Calibri"/>
               </a:rPr>
-              <a:t>Every complaint has to be tagged with the vehicle system it is about</a:t>
+              <a:t>Most owners cannot tell a real safety defect from a harmless quirk</a:t>
             </a:r>
           </a:p>
           <a:p>
@@ -3407,7 +3407,7 @@
                 </a:solidFill>
                 <a:latin typeface="Calibri"/>
               </a:rPr>
-              <a:t>That tagging is mostly manual today, so it is slow and inconsistent</a:t>
+              <a:t>So they worry over nothing, or keep driving through a real problem</a:t>
             </a:r>
           </a:p>
           <a:p>
@@ -3423,7 +3423,7 @@
                 </a:solidFill>
                 <a:latin typeface="Calibri"/>
               </a:rPr>
-              <a:t>These complaints are the early warning for recalls, so speed matters</a:t>
+              <a:t>Recalls start from owner complaints, but only if people recognise and report them</a:t>
             </a:r>
           </a:p>
         </p:txBody>
@@ -3531,7 +3531,7 @@
                 </a:solidFill>
                 <a:latin typeface="Calibri"/>
               </a:rPr>
-              <a:t>What we built</a:t>
+              <a:t>What I built</a:t>
             </a:r>
           </a:p>
         </p:txBody>
@@ -3570,7 +3570,7 @@
                 </a:solidFill>
                 <a:latin typeface="Calibri"/>
               </a:rPr>
-              <a:t>Reads the owner's own words and predicts one of 14 vehicle systems in under a second</a:t>
+              <a:t>Describe the problem in plain words, the way you would tell a friend</a:t>
             </a:r>
           </a:p>
           <a:p>
@@ -3586,7 +3586,7 @@
                 </a:solidFill>
                 <a:latin typeface="Calibri"/>
               </a:rPr>
-              <a:t>Flags how safety-critical the system is and suggests where to route the report</a:t>
+              <a:t>It tells you which of 14 car systems it is, and how serious that system is</a:t>
             </a:r>
           </a:p>
           <a:p>
@@ -3602,7 +3602,7 @@
                 </a:solidFill>
                 <a:latin typeface="Calibri"/>
               </a:rPr>
-              <a:t>Trained on about 37,000 real NHTSA complaints across 14 car makes</a:t>
+              <a:t>And whether it is worth reporting to NHTSA</a:t>
             </a:r>
           </a:p>
           <a:p>
@@ -3618,7 +3618,7 @@
                 </a:solidFill>
                 <a:latin typeface="Calibri"/>
               </a:rPr>
-              <a:t>Not a black box, it shows the exact words behind every decision</a:t>
+              <a:t>It shows the exact words behind the call, so you can decide to trust it</a:t>
             </a:r>
           </a:p>
         </p:txBody>
@@ -3797,7 +3797,7 @@
                 </a:solidFill>
                 <a:latin typeface="Calibri"/>
               </a:rPr>
-              <a:t>Prediction, confidence, and the top 3 candidate systems</a:t>
+              <a:t>Most likely system, confidence, and the other systems it could be</a:t>
             </a:r>
           </a:p>
           <a:p>
@@ -3813,7 +3813,7 @@
                 </a:solidFill>
                 <a:latin typeface="Calibri"/>
               </a:rPr>
-              <a:t>Highlighted words that drove the call, plus a safety triage banner</a:t>
+              <a:t>The words that drove the call, plus a safety tier and a plain next step</a:t>
             </a:r>
           </a:p>
           <a:p>
@@ -3937,7 +3937,7 @@
                 </a:solidFill>
                 <a:latin typeface="Calibri"/>
               </a:rPr>
-              <a:t>Three models, one honest comparison</a:t>
+              <a:t>Three models, judged honestly</a:t>
             </a:r>
           </a:p>
         </p:txBody>
@@ -4594,7 +4594,7 @@
                 </a:solidFill>
                 <a:latin typeface="Calibri"/>
               </a:rPr>
-              <a:t>What we learned</a:t>
+              <a:t>What I learned</a:t>
             </a:r>
           </a:p>
         </p:txBody>
@@ -4665,7 +4665,7 @@
                 </a:solidFill>
                 <a:latin typeface="Calibri"/>
               </a:rPr>
-              <a:t>The classical model stays a bit more robust to typos and noise</a:t>
+              <a:t>For a safety tool, honesty matters: it says 'not sure' instead of a false all-clear</a:t>
             </a:r>
           </a:p>
           <a:p>
@@ -4828,7 +4828,7 @@
                 </a:solidFill>
                 <a:latin typeface="Calibri"/>
               </a:rPr>
-              <a:t>Manual triage becomes real-time triage</a:t>
+              <a:t>Turn a helpless worry into a clear read and a next step</a:t>
             </a:r>
           </a:p>
           <a:p>
@@ -4844,7 +4844,7 @@
                 </a:solidFill>
                 <a:latin typeface="Calibri"/>
               </a:rPr>
-              <a:t>The same engine fits a marketplace, a manufacturer, or a fleet</a:t>
+              <a:t>Every good report an owner files also feeds the recall system</a:t>
             </a:r>
           </a:p>
           <a:p>
@@ -4860,7 +4860,7 @@
                 </a:solidFill>
                 <a:latin typeface="Calibri"/>
               </a:rPr>
-              <a:t>Live on the cloud, a small model, no GPU, and transparent</a:t>
+              <a:t>Live on the cloud, a small model, no GPU, and it explains itself</a:t>
             </a:r>
           </a:p>
           <a:p>
@@ -4876,7 +4876,7 @@
                 </a:solidFill>
                 <a:latin typeface="Calibri"/>
               </a:rPr>
-              <a:t>The ask: a partner complaint stream and a pilot with one quality team</a:t>
+              <a:t>The ask: put it in a car marketplace or claims flow and test it with real owners</a:t>
             </a:r>
           </a:p>
         </p:txBody>

</xml_diff>

<commit_message>
Add an originality slide and resync the script cues
The script now argues why this is new work, but no slide backed it visually,
and the previous project lost five points for originality being unclear.

- New slide 4, 'Why this is new work': the hackathon contrast, the contrast
  against prior research on this database, and what I did differently
- Deck goes from 8 to 9 slides
- Script splits the product beat from the originality beat so each maps to one
  slide, and all cues renumbered to match
- Spoken length unchanged at 468 words, 4:15 at the written pace
</commit_message>
<xml_diff>
--- a/PITCH.pptx
+++ b/PITCH.pptx
@@ -13,6 +13,7 @@
     <p:sldId id="261" r:id="rId12"/>
     <p:sldId id="262" r:id="rId13"/>
     <p:sldId id="263" r:id="rId14"/>
+    <p:sldId id="264" r:id="rId15"/>
   </p:sldIdLst>
   <p:sldSz cx="12191695" cy="6858000" type="screen4x3"/>
   <p:notesSz cx="6858000" cy="9144000"/>
@@ -3726,7 +3727,7 @@
                 </a:solidFill>
                 <a:latin typeface="Calibri"/>
               </a:rPr>
-              <a:t>Live demo</a:t>
+              <a:t>Why this is new work</a:t>
             </a:r>
           </a:p>
           <a:p>
@@ -3742,7 +3743,7 @@
                 </a:solidFill>
                 <a:latin typeface="Calibri"/>
               </a:rPr>
-              <a:t>Let the screen do the talking</a:t>
+              <a:t>Different data, question, model, and user</a:t>
             </a:r>
           </a:p>
         </p:txBody>
@@ -3781,7 +3782,7 @@
                 </a:solidFill>
                 <a:latin typeface="Calibri"/>
               </a:rPr>
-              <a:t>autotriage-ai-unfvnsiy6a-uc.a.run.app</a:t>
+              <a:t>Not my hackathon: that was sentiment on consumer reviews, fine-tuned DistilBERT</a:t>
             </a:r>
           </a:p>
           <a:p>
@@ -3797,7 +3798,7 @@
                 </a:solidFill>
                 <a:latin typeface="Calibri"/>
               </a:rPr>
-              <a:t>Most likely system, confidence, and the other systems it could be</a:t>
+              <a:t>This is safety complaints, which system failed, a TextCNN with GloVe</a:t>
             </a:r>
           </a:p>
           <a:p>
@@ -3813,7 +3814,7 @@
                 </a:solidFill>
                 <a:latin typeface="Calibri"/>
               </a:rPr>
-              <a:t>The words that drove the call, plus a safety tier and a plain next step</a:t>
+              <a:t>Published work on this database clusters it for regulators (Ghazizadeh et al., 2014)</a:t>
             </a:r>
           </a:p>
           <a:p>
@@ -3829,7 +3830,7 @@
                 </a:solidFill>
                 <a:latin typeface="Calibri"/>
               </a:rPr>
-              <a:t>Flip between the naive, classical, and deep models on the same text</a:t>
+              <a:t>I pointed the same data at the owner, with explanations and a safety tier</a:t>
             </a:r>
           </a:p>
         </p:txBody>
@@ -3937,7 +3938,23 @@
                 </a:solidFill>
                 <a:latin typeface="Calibri"/>
               </a:rPr>
-              <a:t>Three models, judged honestly</a:t>
+              <a:t>Live demo</a:t>
+            </a:r>
+          </a:p>
+          <a:p>
+            <a:pPr algn="l">
+              <a:spcAft>
+                <a:spcPts val="400"/>
+              </a:spcAft>
+            </a:pPr>
+            <a:r>
+              <a:rPr sz="1800" b="0">
+                <a:solidFill>
+                  <a:srgbClr val="93A0BD"/>
+                </a:solidFill>
+                <a:latin typeface="Calibri"/>
+              </a:rPr>
+              <a:t>Let the screen do the talking</a:t>
             </a:r>
           </a:p>
         </p:txBody>
@@ -3976,7 +3993,7 @@
                 </a:solidFill>
                 <a:latin typeface="Calibri"/>
               </a:rPr>
-              <a:t>Naive baseline, majority class, the accuracy floor</a:t>
+              <a:t>autotriage-ai-unfvnsiy6a-uc.a.run.app</a:t>
             </a:r>
           </a:p>
           <a:p>
@@ -3992,7 +4009,7 @@
                 </a:solidFill>
                 <a:latin typeface="Calibri"/>
               </a:rPr>
-              <a:t>Classical, TF-IDF with class-weighted Logistic Regression</a:t>
+              <a:t>Most likely system, confidence, and the other systems it could be</a:t>
             </a:r>
           </a:p>
           <a:p>
@@ -4008,7 +4025,7 @@
                 </a:solidFill>
                 <a:latin typeface="Calibri"/>
               </a:rPr>
-              <a:t>Deep, TextCNN with GloVe transfer learning, the deployed model</a:t>
+              <a:t>The words that drove the call, plus a safety tier and a plain next step</a:t>
             </a:r>
           </a:p>
           <a:p>
@@ -4024,7 +4041,7 @@
                 </a:solidFill>
                 <a:latin typeface="Calibri"/>
               </a:rPr>
-              <a:t>The data is long-tailed, so we judge on macro-F1, not accuracy</a:t>
+              <a:t>Flip between the naive, classical, and deep models on the same text</a:t>
             </a:r>
           </a:p>
         </p:txBody>
@@ -4038,6 +4055,201 @@
 </file>
 
 <file path=ppt/slides/slide6.xml><?xml version="1.0" encoding="utf-8"?>
+<p:sld xmlns:a="http://schemas.openxmlformats.org/drawingml/2006/main" xmlns:p="http://schemas.openxmlformats.org/presentationml/2006/main" xmlns:r="http://schemas.openxmlformats.org/officeDocument/2006/relationships">
+  <p:cSld>
+    <p:bg>
+      <p:bgPr>
+        <a:solidFill>
+          <a:srgbClr val="0B1020"/>
+        </a:solidFill>
+        <a:effectLst/>
+      </p:bgPr>
+    </p:bg>
+    <p:spTree>
+      <p:nvGrpSpPr>
+        <p:cNvPr id="1" name=""/>
+        <p:cNvGrpSpPr/>
+        <p:nvPr/>
+      </p:nvGrpSpPr>
+      <p:grpSpPr/>
+      <p:sp>
+        <p:nvSpPr>
+          <p:cNvPr id="2" name="Rectangle 1"/>
+          <p:cNvSpPr/>
+          <p:nvPr/>
+        </p:nvSpPr>
+        <p:spPr>
+          <a:xfrm>
+            <a:off x="822960" y="640080"/>
+            <a:ext cx="146304" cy="502920"/>
+          </a:xfrm>
+          <a:prstGeom prst="rect">
+            <a:avLst/>
+          </a:prstGeom>
+          <a:solidFill>
+            <a:srgbClr val="4CC9F0"/>
+          </a:solidFill>
+          <a:ln>
+            <a:noFill/>
+          </a:ln>
+        </p:spPr>
+        <p:style>
+          <a:lnRef idx="1">
+            <a:schemeClr val="accent1"/>
+          </a:lnRef>
+          <a:fillRef idx="3">
+            <a:schemeClr val="accent1"/>
+          </a:fillRef>
+          <a:effectRef idx="2">
+            <a:schemeClr val="accent1"/>
+          </a:effectRef>
+          <a:fontRef idx="minor">
+            <a:schemeClr val="lt1"/>
+          </a:fontRef>
+        </p:style>
+        <p:txBody>
+          <a:bodyPr rtlCol="0" anchor="ctr"/>
+          <a:lstStyle/>
+          <a:p>
+            <a:pPr algn="ctr"/>
+          </a:p>
+        </p:txBody>
+      </p:sp>
+      <p:sp>
+        <p:nvSpPr>
+          <p:cNvPr id="3" name="TextBox 2"/>
+          <p:cNvSpPr txBox="1"/>
+          <p:nvPr/>
+        </p:nvSpPr>
+        <p:spPr>
+          <a:xfrm>
+            <a:off x="1097280" y="566928"/>
+            <a:ext cx="10058400" cy="914400"/>
+          </a:xfrm>
+          <a:prstGeom prst="rect">
+            <a:avLst/>
+          </a:prstGeom>
+          <a:noFill/>
+        </p:spPr>
+        <p:txBody>
+          <a:bodyPr wrap="square" anchor="t">
+            <a:spAutoFit/>
+          </a:bodyPr>
+          <a:lstStyle/>
+          <a:p>
+            <a:pPr algn="l">
+              <a:spcAft>
+                <a:spcPts val="1000"/>
+              </a:spcAft>
+            </a:pPr>
+            <a:r>
+              <a:rPr sz="3400" b="1">
+                <a:solidFill>
+                  <a:srgbClr val="E8EDF7"/>
+                </a:solidFill>
+                <a:latin typeface="Calibri"/>
+              </a:rPr>
+              <a:t>Three models, judged honestly</a:t>
+            </a:r>
+          </a:p>
+        </p:txBody>
+      </p:sp>
+      <p:sp>
+        <p:nvSpPr>
+          <p:cNvPr id="4" name="TextBox 3"/>
+          <p:cNvSpPr txBox="1"/>
+          <p:nvPr/>
+        </p:nvSpPr>
+        <p:spPr>
+          <a:xfrm>
+            <a:off x="1097280" y="1783080"/>
+            <a:ext cx="10058400" cy="4572000"/>
+          </a:xfrm>
+          <a:prstGeom prst="rect">
+            <a:avLst/>
+          </a:prstGeom>
+          <a:noFill/>
+        </p:spPr>
+        <p:txBody>
+          <a:bodyPr wrap="square" anchor="t">
+            <a:spAutoFit/>
+          </a:bodyPr>
+          <a:lstStyle/>
+          <a:p>
+            <a:pPr algn="l">
+              <a:spcAft>
+                <a:spcPts val="1800"/>
+              </a:spcAft>
+            </a:pPr>
+            <a:r>
+              <a:rPr sz="2200" b="0">
+                <a:solidFill>
+                  <a:srgbClr val="E8EDF7"/>
+                </a:solidFill>
+                <a:latin typeface="Calibri"/>
+              </a:rPr>
+              <a:t>Naive baseline, majority class, the accuracy floor</a:t>
+            </a:r>
+          </a:p>
+          <a:p>
+            <a:pPr algn="l">
+              <a:spcAft>
+                <a:spcPts val="1800"/>
+              </a:spcAft>
+            </a:pPr>
+            <a:r>
+              <a:rPr sz="2200" b="0">
+                <a:solidFill>
+                  <a:srgbClr val="E8EDF7"/>
+                </a:solidFill>
+                <a:latin typeface="Calibri"/>
+              </a:rPr>
+              <a:t>Classical, TF-IDF with class-weighted Logistic Regression</a:t>
+            </a:r>
+          </a:p>
+          <a:p>
+            <a:pPr algn="l">
+              <a:spcAft>
+                <a:spcPts val="1800"/>
+              </a:spcAft>
+            </a:pPr>
+            <a:r>
+              <a:rPr sz="2200" b="0">
+                <a:solidFill>
+                  <a:srgbClr val="E8EDF7"/>
+                </a:solidFill>
+                <a:latin typeface="Calibri"/>
+              </a:rPr>
+              <a:t>Deep, TextCNN with GloVe transfer learning, the deployed model</a:t>
+            </a:r>
+          </a:p>
+          <a:p>
+            <a:pPr algn="l">
+              <a:spcAft>
+                <a:spcPts val="1800"/>
+              </a:spcAft>
+            </a:pPr>
+            <a:r>
+              <a:rPr sz="2200" b="0">
+                <a:solidFill>
+                  <a:srgbClr val="E8EDF7"/>
+                </a:solidFill>
+                <a:latin typeface="Calibri"/>
+              </a:rPr>
+              <a:t>The data is long-tailed, so we judge on macro-F1, not accuracy</a:t>
+            </a:r>
+          </a:p>
+        </p:txBody>
+      </p:sp>
+    </p:spTree>
+  </p:cSld>
+  <p:clrMapOvr>
+    <a:masterClrMapping/>
+  </p:clrMapOvr>
+</p:sld>
+</file>
+
+<file path=ppt/slides/slide7.xml><?xml version="1.0" encoding="utf-8"?>
 <p:sld xmlns:a="http://schemas.openxmlformats.org/drawingml/2006/main" xmlns:p="http://schemas.openxmlformats.org/presentationml/2006/main" xmlns:r="http://schemas.openxmlformats.org/officeDocument/2006/relationships">
   <p:cSld>
     <p:bg>
@@ -4499,7 +4711,7 @@
 </p:sld>
 </file>
 
-<file path=ppt/slides/slide7.xml><?xml version="1.0" encoding="utf-8"?>
+<file path=ppt/slides/slide8.xml><?xml version="1.0" encoding="utf-8"?>
 <p:sld xmlns:a="http://schemas.openxmlformats.org/drawingml/2006/main" xmlns:p="http://schemas.openxmlformats.org/presentationml/2006/main" xmlns:r="http://schemas.openxmlformats.org/officeDocument/2006/relationships">
   <p:cSld>
     <p:bg>
@@ -4694,7 +4906,7 @@
 </p:sld>
 </file>
 
-<file path=ppt/slides/slide8.xml><?xml version="1.0" encoding="utf-8"?>
+<file path=ppt/slides/slide9.xml><?xml version="1.0" encoding="utf-8"?>
 <p:sld xmlns:a="http://schemas.openxmlformats.org/drawingml/2006/main" xmlns:p="http://schemas.openxmlformats.org/presentationml/2006/main" xmlns:r="http://schemas.openxmlformats.org/officeDocument/2006/relationships">
   <p:cSld>
     <p:bg>

</xml_diff>